<commit_message>
docs: aggiorna pitch deck con footer 'Powered by GeneForge AI Labs'
</commit_message>
<xml_diff>
--- a/Pitch_Deck_Studio_Legale_AI_OAL_Settembre2026.pptx
+++ b/Pitch_Deck_Studio_Legale_AI_OAL_Settembre2026.pptx
@@ -3327,7 +3327,7 @@
               </a:defRPr>
             </a:pPr>
             <a:r>
-              <a:t>Studio Legale AI — Powered by GeneForge AI</a:t>
+              <a:t>Studio Legale AI — Powered by GeneForge AI Labs</a:t>
             </a:r>
           </a:p>
         </p:txBody>
@@ -3988,7 +3988,7 @@
               </a:defRPr>
             </a:pPr>
             <a:r>
-              <a:t>Studio Legale AI — Powered by GeneForge AI</a:t>
+              <a:t>Studio Legale AI — Powered by GeneForge AI Labs</a:t>
             </a:r>
           </a:p>
         </p:txBody>
@@ -4417,7 +4417,7 @@
               </a:defRPr>
             </a:pPr>
             <a:r>
-              <a:t>Studio Legale AI — Powered by GeneForge AI</a:t>
+              <a:t>Studio Legale AI — Powered by GeneForge AI Labs</a:t>
             </a:r>
           </a:p>
         </p:txBody>
@@ -4740,7 +4740,7 @@
               </a:defRPr>
             </a:pPr>
             <a:r>
-              <a:t>Studio Legale AI — Powered by GeneForge AI</a:t>
+              <a:t>Studio Legale AI — Powered by GeneForge AI Labs</a:t>
             </a:r>
           </a:p>
         </p:txBody>
@@ -5169,7 +5169,7 @@
               </a:defRPr>
             </a:pPr>
             <a:r>
-              <a:t>Studio Legale AI — Powered by GeneForge AI</a:t>
+              <a:t>Studio Legale AI — Powered by GeneForge AI Labs</a:t>
             </a:r>
           </a:p>
         </p:txBody>
@@ -6068,7 +6068,7 @@
               </a:defRPr>
             </a:pPr>
             <a:r>
-              <a:t>Studio Legale AI — Powered by GeneForge AI</a:t>
+              <a:t>Studio Legale AI — Powered by GeneForge AI Labs</a:t>
             </a:r>
           </a:p>
         </p:txBody>
@@ -6407,7 +6407,7 @@
               </a:defRPr>
             </a:pPr>
             <a:r>
-              <a:t>Studio Legale AI — Powered by GeneForge AI</a:t>
+              <a:t>Studio Legale AI — Powered by GeneForge AI Labs</a:t>
             </a:r>
           </a:p>
         </p:txBody>
@@ -7499,7 +7499,7 @@
               </a:defRPr>
             </a:pPr>
             <a:r>
-              <a:t>Studio Legale AI — Powered by GeneForge AI</a:t>
+              <a:t>Studio Legale AI — Powered by GeneForge AI Labs</a:t>
             </a:r>
           </a:p>
         </p:txBody>
@@ -7928,7 +7928,7 @@
               </a:defRPr>
             </a:pPr>
             <a:r>
-              <a:t>Studio Legale AI — Powered by GeneForge AI</a:t>
+              <a:t>Studio Legale AI — Powered by GeneForge AI Labs</a:t>
             </a:r>
           </a:p>
         </p:txBody>
@@ -8251,7 +8251,7 @@
               </a:defRPr>
             </a:pPr>
             <a:r>
-              <a:t>Studio Legale AI — Powered by GeneForge AI</a:t>
+              <a:t>Studio Legale AI — Powered by GeneForge AI Labs</a:t>
             </a:r>
           </a:p>
         </p:txBody>
@@ -8574,7 +8574,7 @@
               </a:defRPr>
             </a:pPr>
             <a:r>
-              <a:t>Studio Legale AI — Powered by GeneForge AI</a:t>
+              <a:t>Studio Legale AI — Powered by GeneForge AI Labs</a:t>
             </a:r>
           </a:p>
         </p:txBody>
@@ -9035,7 +9035,7 @@
               </a:defRPr>
             </a:pPr>
             <a:r>
-              <a:t>Studio Legale AI — Powered by GeneForge AI</a:t>
+              <a:t>Studio Legale AI — Powered by GeneForge AI Labs</a:t>
             </a:r>
           </a:p>
         </p:txBody>
@@ -9395,7 +9395,7 @@
               </a:defRPr>
             </a:pPr>
             <a:r>
-              <a:t>Studio Legale AI — Powered by GeneForge AI</a:t>
+              <a:t>Studio Legale AI — Powered by GeneForge AI Labs</a:t>
             </a:r>
           </a:p>
         </p:txBody>
@@ -9734,7 +9734,7 @@
               </a:defRPr>
             </a:pPr>
             <a:r>
-              <a:t>Studio Legale AI — Powered by GeneForge AI</a:t>
+              <a:t>Studio Legale AI — Powered by GeneForge AI Labs</a:t>
             </a:r>
           </a:p>
         </p:txBody>
@@ -10227,7 +10227,7 @@
               </a:defRPr>
             </a:pPr>
             <a:r>
-              <a:t>Studio Legale AI — Powered by GeneForge AI</a:t>
+              <a:t>Studio Legale AI — Powered by GeneForge AI Labs</a:t>
             </a:r>
           </a:p>
         </p:txBody>
@@ -11092,7 +11092,7 @@
               </a:defRPr>
             </a:pPr>
             <a:r>
-              <a:t>Studio Legale AI — Powered by GeneForge AI</a:t>
+              <a:t>Studio Legale AI — Powered by GeneForge AI Labs</a:t>
             </a:r>
           </a:p>
         </p:txBody>
@@ -11821,7 +11821,7 @@
               </a:defRPr>
             </a:pPr>
             <a:r>
-              <a:t>Studio Legale AI — Powered by GeneForge AI</a:t>
+              <a:t>Studio Legale AI — Powered by GeneForge AI Labs</a:t>
             </a:r>
           </a:p>
         </p:txBody>
@@ -12314,7 +12314,7 @@
               </a:defRPr>
             </a:pPr>
             <a:r>
-              <a:t>Studio Legale AI — Powered by GeneForge AI</a:t>
+              <a:t>Studio Legale AI — Powered by GeneForge AI Labs</a:t>
             </a:r>
           </a:p>
         </p:txBody>
@@ -12653,7 +12653,7 @@
               </a:defRPr>
             </a:pPr>
             <a:r>
-              <a:t>Studio Legale AI — Powered by GeneForge AI</a:t>
+              <a:t>Studio Legale AI — Powered by GeneForge AI Labs</a:t>
             </a:r>
           </a:p>
         </p:txBody>
@@ -13082,7 +13082,7 @@
               </a:defRPr>
             </a:pPr>
             <a:r>
-              <a:t>Studio Legale AI — Powered by GeneForge AI</a:t>
+              <a:t>Studio Legale AI — Powered by GeneForge AI Labs</a:t>
             </a:r>
           </a:p>
         </p:txBody>

</xml_diff>